<commit_message>
Rewrite presenter notes as the delta, not the slide text
The slide says it, so the notes don't: each slide now carries only the
story (Dave cold open, the Gell-Mann page-turn), the reason behind each
line, window choreography, timing/stretch levers, and the transition
cue. deck-presenter.pptx rebuilt.

Co-Authored-By: Claude Fable 5 <noreply@anthropic.com>
</commit_message>
<xml_diff>
--- a/slides/deck-presenter.pptx
+++ b/slides/deck-presenter.pptx
@@ -514,37 +514,43 @@
           <a:lstStyle/>
           <a:p>
             <a:r>
-              <a:t>**Before you start:** this slide up as people arrive; poll QR live. Point at it once: *"While you arrive — one question."*</a:t>
+              <a:t>Slide is up as people arrive, poll QR live. Point once: *"While you arrive — one question."*</a:t>
             </a:r>
           </a:p>
           <a:p/>
           <a:p>
             <a:r>
-              <a:t>**Say:** the provocation, verbatim: *"AI can now draft your copy, model your numbers, and rehearse your pitch — which means it can do the same for every other founder in the room. When a capability becomes universal, generic competence stops being an advantage. So where does your edge actually live?"*</a:t>
+              <a:t>**Cold open — tell Dave's story, don't welcome anyone yet.** *"Picture a sparkie — call him Dave. Sole trader out of Midland, turns over about $300k. Somewhere in his ute is a glovebox stuffed with receipts, and he's a full BAS quarter behind. Here's the thing — Dave doesn't hate tax. He hates the chair: the sitting-down-at-9pm-with-a-laptop part. He'll do a 12-hour day in 40-degree heat, no worries; ask him to file a receipt and he'll find literally anything else to do."*</a:t>
             </a:r>
           </a:p>
           <a:p/>
           <a:p>
             <a:r>
-              <a:t>Show of hands: *"Who's used AI on their idea this week?"* Don't dwell.</a:t>
+              <a:t>Then the turn: *"In about ten minutes, we're going to pitch an app that rescues Dave to an AI — live — and you're going to watch that AI lie to us. Then we're going to fix it."*</a:t>
             </a:r>
           </a:p>
           <a:p/>
           <a:p>
             <a:r>
-              <a:t>Housekeeping (20 s): *"The slides are signposts, not the handout. The companion site is the handout — every prompt we run today lives there. Scan it now; it comes back on screen when we go live."*</a:t>
+              <a:t>Now the provocation — deliver it as your own claim, don't read the quote block. The question at the end ("where does your edge actually live?") is the whole hour; let it hang for two seconds.</a:t>
             </a:r>
           </a:p>
           <a:p/>
           <a:p>
             <a:r>
-              <a:t>**Do:** glance at the poll histogram — mostly A/B → slow the follow-along instruction later; mostly C/D → push the parallel work harder.</a:t>
+              <a:t>Show of hands (who's used AI this week) — count it, don't discuss it. Housekeeping: slides are signposts, the site is the handout, scan now or later.</a:t>
             </a:r>
           </a:p>
           <a:p/>
           <a:p>
             <a:r>
-              <a:t>**Advance:** after the housekeeping line.</a:t>
+              <a:t>**Do:** glance at the poll histogram. Mostly A/B → slow the follow-along later. Mostly C/D → push the parallel work harder.</a:t>
+            </a:r>
+          </a:p>
+          <a:p/>
+          <a:p>
+            <a:r>
+              <a:t>**Advance:** off the hanging question.</a:t>
             </a:r>
           </a:p>
         </p:txBody>
@@ -614,13 +620,13 @@
           <a:lstStyle/>
           <a:p>
             <a:r>
-              <a:t>**Say, one line each:** the *devil's advocate* — you just did it in move 2. The *board of directors* — same question to a room of voices (cautious CFO, sceptical customer, growth marketer); they advise, you decide. And *VET* — Verify the source, Explain it back, Test the edges — for any claim you can't check. Prompts for all three on the site.</a:t>
+              <a:t>The slide lists them; you only connect and locate. Devil's advocate — *"you just watched it."* Board of directors — one colour line: *"the CFO in that room will hate your pricing; better to hear it from a fake CFO for free."* VET — point forward: *"that one earns its keep in two minutes."* All three prompts on the site.</a:t>
             </a:r>
           </a:p>
           <a:p/>
           <a:p>
             <a:r>
-              <a:t>**Advance:** into the trust tool; VET earns its keep there.</a:t>
+              <a:t>**Advance:** briskly. This slide is a landing, not a lecture.</a:t>
             </a:r>
           </a:p>
         </p:txBody>
@@ -690,25 +696,25 @@
           <a:lstStyle/>
           <a:p>
             <a:r>
-              <a:t>**Say:** one grid, taught once — Average/Precise × Small/Large. Walk the founder examples on the slide: lean in for competitor scans, brainstorming, first drafts; human owns the go/no-go, the customer, any number in a pitch or contract.</a:t>
+              <a:t>The grid is on the slide; you supply the sorting exercise. Give the room two concrete calls to make: *"Market-sizing first pass — which box?"* (lean in, verify lightly). *"The revenue number in your pitch deck?"* (human owns it, full stop). Let them answer out loud; correcting a wrong answer teaches the grid better than presenting it.</a:t>
             </a:r>
           </a:p>
           <a:p/>
           <a:p>
             <a:r>
-              <a:t>The keeper sentence: *"Where it hurts to be wrong, you stay in charge."*</a:t>
+              <a:t>The keeper line, verbatim, once: *"Where it hurts to be wrong, you stay in charge."*</a:t>
             </a:r>
           </a:p>
           <a:p/>
           <a:p>
             <a:r>
-              <a:t>And the how of the verify column: VET — it's in the starter prompts as "VET the claim."</a:t>
+              <a:t>Close the loop from slide 10: VET is *how* you do the verify column — it's in the starter prompts as "VET the claim."</a:t>
             </a:r>
           </a:p>
           <a:p/>
           <a:p>
             <a:r>
-              <a:t>**Advance:** at the 53-minute mark.</a:t>
+              <a:t>**Advance:** at ~53:00.</a:t>
             </a:r>
           </a:p>
         </p:txBody>
@@ -778,19 +784,19 @@
           <a:lstStyle/>
           <a:p>
             <a:r>
-              <a:t>**Say, slowly — this is what they repeat Monday morning:** Add context — the specifics only you hold. Prompt past the flattery — never "what do you think?", always "why does this fail?". Stay sceptical where you know least.</a:t>
+              <a:t>Everything is on the slide. Your only job: connect each line to the moment they watched it happen — context → pass 2 of move 1; past the flattery → move 2's verdict; sceptical where you know least → the Gell-Mann page-turn. *"You didn't learn a theory today. You watched all three."*</a:t>
             </a:r>
           </a:p>
           <a:p/>
           <a:p>
             <a:r>
-              <a:t>Thesis, third landing: *"AI as a thinking partner, not a stand-in."*</a:t>
+              <a:t>Thesis, third landing: thinking partner, not stand-in.</a:t>
             </a:r>
           </a:p>
           <a:p/>
           <a:p>
             <a:r>
-              <a:t>**Advance:** into takeaways.</a:t>
+              <a:t>**Advance:** into the close.</a:t>
             </a:r>
           </a:p>
         </p:txBody>
@@ -860,19 +866,19 @@
           <a:lstStyle/>
           <a:p>
             <a:r>
-              <a:t>**Say:** the site is the handout — RTCF builder, prompt library, trust tool, all of today's prompts. Tonight: run move 1 on your real idea — naive first, then with your edge; feel the difference. Tools beyond free chat — Gemini Notebook for your documents, Msty for private local AI — all linked.</a:t>
+              <a:t>Make it one action, not four bullets: *"Tonight, before you lose the nerve: run move 1 on your real idea. Naive first, then with your edge. When you feel the difference — that feeling is the method."* Everything else — the builder, the library, Notebook, Msty — is on the site, and the site is bookmarked.</a:t>
             </a:r>
           </a:p>
           <a:p/>
           <a:p>
             <a:r>
-              <a:t>**Close on the line:** *"Direct it. Don't delegate. Never surrender."*</a:t>
+              <a:t>Close on the line, then stop talking: *"Direct it. Don't delegate. Never surrender."*</a:t>
             </a:r>
           </a:p>
           <a:p/>
           <a:p>
             <a:r>
-              <a:t>**Do:** leave this slide up as they go — the QR keeps working.</a:t>
+              <a:t>**Do:** leave the slide up as they pack — the QR keeps working.</a:t>
             </a:r>
           </a:p>
         </p:txBody>
@@ -942,13 +948,19 @@
           <a:lstStyle/>
           <a:p>
             <a:r>
-              <a:t>**Say:** walk the three rows top to bottom — same capability, every founder in the room; generic competence is the baseline, not the advantage; the edge lives in your judgement: taste, context, variation no rival's identical model reproduces.</a:t>
+              <a:t>The slide states the claim; your job is to make it personal. Land it with the room, not the abstract: *"While you've been sitting here, everyone else in this room could ask the same model for the same market scan, the same pitch, the same plan — and get the same good answer. If you all have the same brilliant assistant, none of you has an advantage."*</a:t>
             </a:r>
           </a:p>
           <a:p/>
           <a:p>
             <a:r>
-              <a:t>**Advance:** when the judgement line lands. You'll return to this thesis twice more — after the two-pass reveal, and at the close.</a:t>
+              <a:t>Don't read the three rows — point at the last one and slow down on **judgement**: taste, context, the thing no identical model can copy. This claim comes back twice more (after the two-pass reveal, and at the close); it earns belief in the demo, not here.</a:t>
+            </a:r>
+          </a:p>
+          <a:p/>
+          <a:p>
+            <a:r>
+              <a:t>**Advance:** as soon as "judgement" lands. Don't linger — this slide is a promise, not a proof.</a:t>
             </a:r>
           </a:p>
         </p:txBody>
@@ -1018,19 +1030,25 @@
           <a:lstStyle/>
           <a:p>
             <a:r>
-              <a:t>**Say (30 s, dry understatement):** ~30 tools shipped solo, in conversation with AI. AI taught at undergrad, postgrad, exec ed. Then the line that matters: *"the deck you're watching, the site you scanned, and the poll you just answered were all built in conversation with AI."* Move on.</a:t>
+              <a:t>The slide shows the résumé; you supply the tone — dry, fast, almost throwaway. The unspoken question you're answering: "has this person actually done it, or do they just lecture about it?"</a:t>
             </a:r>
           </a:p>
           <a:p/>
           <a:p>
             <a:r>
-              <a:t>**Then name the demo idea (one line, before you advance):** *"We're going to take one idea through three moves, live — a receipt-scanning app for Australian tradies — and you'll run the same moves on your own idea at the same time."*</a:t>
+              <a:t>The one line to deliver with a beat of silence after: *"the deck you're watching, the site you scanned, and the poll you just answered were all built in conversation with AI."* Don't elaborate. Understatement is the credibility.</a:t>
             </a:r>
           </a:p>
           <a:p/>
           <a:p>
             <a:r>
-              <a:t>**Advance:** straight into the traps.</a:t>
+              <a:t>**Transition:** *"So — Dave's app. Let's find out what it's up against first."*</a:t>
+            </a:r>
+          </a:p>
+          <a:p/>
+          <a:p>
+            <a:r>
+              <a:t>**Advance:** on that line.</a:t>
             </a:r>
           </a:p>
         </p:txBody>
@@ -1100,19 +1118,25 @@
           <a:lstStyle/>
           <a:p>
             <a:r>
-              <a:t>**Say:** *"The model tells you what you want to hear. Ask 'what do you think of my idea?' and you get praise first, gentle criticism second. It's managing your feelings, not assessing your work. It's not a bug — it's how the model was trained."* This is the trap that makes founders stop iterating.</a:t>
+              <a:t>The slide names the trap; you supply the *why* and the *cost*. Why it happens: the model was trained on human approval — agreeable answers score better. It's not lying, it's people-pleasing at scale.</a:t>
             </a:r>
           </a:p>
           <a:p/>
           <a:p>
             <a:r>
-              <a:t>**Plant the defence:** *"The defence is to prompt past it — and that's exactly what move 2 does."*</a:t>
+              <a:t>The cost, for founders specifically: praise stops iteration. *"The most dangerous thing a founder can hear in month one is 'great idea' — because you stop stress-testing exactly when stress-testing is cheapest."*</a:t>
             </a:r>
           </a:p>
           <a:p/>
           <a:p>
             <a:r>
-              <a:t>**Advance:** once the defence is planted.</a:t>
+              <a:t>Tease, don't teach, the defence: *"You can prompt straight past this — you'll watch it happen in about twenty minutes."*</a:t>
+            </a:r>
+          </a:p>
+          <a:p/>
+          <a:p>
+            <a:r>
+              <a:t>**Advance:** on the tease.</a:t>
             </a:r>
           </a:p>
         </p:txBody>
@@ -1182,25 +1206,37 @@
           <a:lstStyle/>
           <a:p>
             <a:r>
-              <a:t>**Say:** *"You catch the AI's errors in your own domain, then trust it blindly on the market, the regulations, the numbers — the bits you can't check. Smooth prose feels authoritative. Smoothness and accuracy are unrelated."*</a:t>
+              <a:t>Tell the origin story — it's not on the slide and it's why the name sticks. *"Michael Crichton named this after his friend, the physicist Murray Gell-Mann. You open the newspaper, read an article on something you actually know, and it's riddled with errors. Then you turn the page to the finance section — and read it as if it's gospel. Same paper. Same journalists. You knew they got your field wrong, and you forgot it one page later."*</a:t>
             </a:r>
           </a:p>
           <a:p/>
           <a:p>
             <a:r>
-              <a:t>Defence: the same scepticism where you know least — more, if anything, because you have fewer tools to catch the errors.</a:t>
+              <a:t>Then map it: your domain = the trade, the product. The page you turn to = the market size, the regs, the numbers. AI writes every page with the same confident fluency.</a:t>
             </a:r>
           </a:p>
           <a:p/>
           <a:p>
             <a:r>
-              <a:t>(Dismissal Fallacy is deliberately skipped — don't mention it.)</a:t>
+              <a:t>Defence in one line: be *most* sceptical where you know *least* — inverted from what feels natural.</a:t>
             </a:r>
           </a:p>
           <a:p/>
           <a:p>
             <a:r>
-              <a:t>**Advance:** into the live block. This is the minute-12 mark.</a:t>
+              <a:t>(Dismissal Fallacy is deliberately cut — don't mention it.)</a:t>
+            </a:r>
+          </a:p>
+          <a:p/>
+          <a:p>
+            <a:r>
+              <a:t>**Transition:** *"Right. Everyone open a chat window — we're going to Dave's rescue."* This is the minute-12 mark.</a:t>
+            </a:r>
+          </a:p>
+          <a:p/>
+          <a:p>
+            <a:r>
+              <a:t>**Advance:** as laptops open.</a:t>
             </a:r>
           </a:p>
         </p:txBody>
@@ -1270,25 +1306,25 @@
           <a:lstStyle/>
           <a:p>
             <a:r>
-              <a:t>**Say first — the IP beat, before anyone pastes:** *"A free chatbot is someone else's cloud — what you paste goes to that company. If your idea is commercially sensitive, don't paste it today: work the tradie example with us now, and run your idea tonight on a local model — one install, Msty, nothing leaves your laptop; it's on the site. Cloud models are the strongest; local models are weaker but yours. That trade never goes away."*</a:t>
+              <a:t>Choreography slide — almost everything here is Do, not Say.</a:t>
             </a:r>
           </a:p>
           <a:p/>
           <a:p>
             <a:r>
-              <a:t>**Then the instruction:** open one of the free chats on the slide. Run each move on YOUR idea in parallel with the tradie demo — or just watch. Both work. Follow-along QR is on this slide.</a:t>
+              <a:t>**Say the IP beat first, before anyone pastes** (verbatim, it's rehearsed): free chat is someone else's cloud; sensitive idea → work the tradie example now, run yours tonight in Msty; frontier power vs privacy is a founder decision that never goes away. This gives permission to watch instead of paste — some of the room needs that permission.</a:t>
             </a:r>
           </a:p>
           <a:p/>
           <a:p>
             <a:r>
-              <a:t>**Do:** open the companion site on the projector, scroll to the session prompts (`#session`) — the room sees the handout being used. Open the fresh chat tab beside it.</a:t>
+              <a:t>**Do, in order:** (1) companion site on the projector, scroll to the session prompts — say *"everything I paste today comes from your handout, in order — nothing up my sleeve."* (2) Fresh chat tab beside it. (3) Confirm the room is in: *"One of the three free chats on screen — you run your idea in parallel, or just watch. Both work."*</a:t>
             </a:r>
           </a:p>
           <a:p/>
           <a:p>
             <a:r>
-              <a:t>**Advance:** to slide 7 as you copy session prompt 1.</a:t>
+              <a:t>**Advance:** to slide 7 as you copy prompt 1. From here to slide 10 the deck is a backdrop.</a:t>
             </a:r>
           </a:p>
         </p:txBody>
@@ -1358,43 +1394,31 @@
           <a:lstStyle/>
           <a:p>
             <a:r>
-              <a:t>Slide is the backdrop; the work happens in the browser.</a:t>
+              <a:t>**Pass 1:** paste prompt 1. While it generates, narrate the dead air: *"Watch how happy it's about to be."* Let the love-fest scroll in silence for a few seconds — the scrolling IS the joke. Then: *"It just told a stranger their idea is brilliant. That's the trap from slide four, live — and it would say it to every founder in this room."*</a:t>
             </a:r>
           </a:p>
           <a:p/>
           <a:p>
             <a:r>
-              <a:t>**Do — pass 1:** paste session prompt 1 (naive validate) into the chat. Let the love-fest scroll.</a:t>
+              <a:t>**Pass 2:** back to the site — prompt 2. Before sending, point at the slide's Role · Task · **Context** · Format and say what the pasted version doesn't: Context is the only part the model can't invent. Dave's context — the $150–400k sole trader, the bookkeeper-shaped competitors, the penalties-not-deductions bet — took a founder to know.</a:t>
             </a:r>
           </a:p>
           <a:p/>
           <a:p>
             <a:r>
-              <a:t>**Say:** *"This just told a stranger their idea is brilliant — the sycophancy trap we named ten minutes ago, live. It's useful, but it's managing my feelings, and it would say it to every founder in this room."*</a:t>
+              <a:t>When it returns, the reveal, slowly: *"Same model. Same idea. Sixty seconds apart. The AI did not get smarter — I directed it."* Thesis, second landing.</a:t>
             </a:r>
           </a:p>
           <a:p/>
           <a:p>
             <a:r>
-              <a:t>**Do — pass 2:** back to the site, copy session prompt 2 (with edge). Before sending, walk its parts against the slide: Role · Task · **Context** · Format — the paste-as-is version has no tags; the labels are on the slide and in the site's template.</a:t>
+              <a:t>**Hold in your head:** this same model calls the idea a PIVOT with a $50 experiment in move 2. Don't foreshadow it to the room — the surprise is the payoff.</a:t>
             </a:r>
           </a:p>
           <a:p/>
           <a:p>
             <a:r>
-              <a:t>**Say when it returns:** same model, same idea — now a sceptical investor, three assumptions ranked by risk, the scariest first. *"The AI did not get smarter. I directed it."* Then the thesis, second landing: *"The Context line is the whole session in one box. No model supplies it."*</a:t>
-            </a:r>
-          </a:p>
-          <a:p/>
-          <a:p>
-            <a:r>
-              <a:t>**Hold this thought:** the same model that just said "genuinely brilliant" will call this a PIVOT with a $50 experiment by move 2. Name that arc when you get there.</a:t>
-            </a:r>
-          </a:p>
-          <a:p/>
-          <a:p>
-            <a:r>
-              <a:t>**Advance:** to slide 8 as you copy session prompt 3.</a:t>
+              <a:t>**Advance:** to slide 8 as you copy prompt 3.</a:t>
             </a:r>
           </a:p>
         </p:txBody>
@@ -1464,31 +1488,37 @@
           <a:lstStyle/>
           <a:p>
             <a:r>
-              <a:t>**Do:** paste session prompt 3 (do not flatter me / three reasons this fails). Read the failures out. Then session prompt 4 (Scale / Pivot / Kill + cheapest experiment).</a:t>
+              <a:t>Paste prompt 3. Read the three failure reasons out loud — slower than feels natural; this is the room hearing an AI be genuinely useful for the first time today. Then prompt 4.</a:t>
             </a:r>
           </a:p>
           <a:p/>
           <a:p>
             <a:r>
-              <a:t>**Say — name the arc:** *"Ten minutes ago this model called the idea genuinely brilliant. Now it says PIVOT and prescribes a $50 experiment. Cheerleader to honest critic to cheap test — that's the whole session in one thread."*</a:t>
+              <a:t>**The arc — name it the moment the verdict lands:** *"Twenty minutes ago this model said 'genuinely brilliant.' Now it says PIVOT and prescribes a fifty-dollar experiment. Cheerleader, honest critic, cheap test — same thread. That arc is the entire session."*</a:t>
             </a:r>
           </a:p>
           <a:p/>
           <a:p>
             <a:r>
-              <a:t>**Normalise killing, out loud:** a fast, cheap kill beats a slow, expensive one.</a:t>
+              <a:t>Normalise the kill — the room needs to hear a lecturer say it: *"If it had said Kill, that's a win. A fast cheap kill is the best deal in startups; the expensive version of this lesson costs eighteen months."*</a:t>
             </a:r>
           </a:p>
           <a:p/>
           <a:p>
             <a:r>
-              <a:t>**Name it:** what we just did is the *devil's advocate* — first of three push-back tools; the other two get one line each after move 3.</a:t>
+              <a:t>Name the tool as you leave: what we just ran is the *devil's advocate* — the first of three; the other two get one line each later.</a:t>
             </a:r>
           </a:p>
           <a:p/>
           <a:p>
             <a:r>
-              <a:t>**Advance:** to slide 9 as you copy session prompt 5. (Time check: behind at minute 36? Cut move 3's second pass — never the two-pass reveal.)</a:t>
+              <a:t>**Time check at 36:** behind → cut move 3's pass 2, never the reveal.</a:t>
+            </a:r>
+          </a:p>
+          <a:p/>
+          <a:p>
+            <a:r>
+              <a:t>**Advance:** to slide 9 as you copy prompt 5.</a:t>
             </a:r>
           </a:p>
         </p:txBody>
@@ -1558,25 +1588,31 @@
           <a:lstStyle/>
           <a:p>
             <a:r>
-              <a:t>**Do — pass 1:** paste session prompt 5 (generic 60-word pitch). **Say:** slick, forgettable, the average.</a:t>
+              <a:t>Pass 1 (prompt 5): when the generic pitch appears, ask the room, don't tell: *"Would you remember this tomorrow? Neither would an investor."*</a:t>
             </a:r>
           </a:p>
           <a:p/>
           <a:p>
             <a:r>
-              <a:t>**Do — pass 2:** paste session prompt 6 — the ~100-word tradie voice sample is baked in ("they don't hate tax — they hate the chair"). The room uses the template with their *own* writing.</a:t>
+              <a:t>Pass 2 (prompt 6): before sending, read Dave's voice sample aloud with the accent it deserves — "they don't hate tax, they hate the chair" gets a laugh and *earns* the contrast. The room pastes their own writing via the template.</a:t>
             </a:r>
           </a:p>
           <a:p/>
           <a:p>
             <a:r>
-              <a:t>**Say:** compare the two pitches side by side on the projector. The difference *is* the edge. One-line nod: make it permanent with a style brief in your custom instructions — the two-page voice method, linked on the site.</a:t>
+              <a:t>Put both pitches side by side and shut up for five seconds. Then: *"Nothing changed except whose words went in. The difference is the edge."*</a:t>
             </a:r>
           </a:p>
           <a:p/>
           <a:p>
             <a:r>
-              <a:t>**Advance:** to slide 10 for the trio.</a:t>
+              <a:t>One-line nod, no more: the style-brief trick makes this permanent — it's linked on the site.</a:t>
+            </a:r>
+          </a:p>
+          <a:p/>
+          <a:p>
+            <a:r>
+              <a:t>**Advance:** to slide 10, energy up — the live block is done, stick the landing.</a:t>
             </a:r>
           </a:p>
         </p:txBody>

</xml_diff>

<commit_message>
Reframe presenter notes for a Builder-heavy room
Pre-poll ran ~50% "AI is part of how I run my venture". Spine
unchanged; framing shifts to peer-not-teacher: the poll result becomes
thesis evidence in the hook, the traps become heavy-user traps, move
1's pass 1 is the control not a lesson, pass 2 lands context-as-moat,
plus a fast-finisher escalation and reprioritised stretch levers.

Co-Authored-By: Claude Fable 5 <noreply@anthropic.com>
</commit_message>
<xml_diff>
--- a/slides/deck-presenter.pptx
+++ b/slides/deck-presenter.pptx
@@ -532,6 +532,12 @@
           <a:p/>
           <a:p>
             <a:r>
+              <a:t>**Then use the poll as the thesis, demonstrated.** Glance at the histogram and say what it shows: *"Half of you told us AI is already part of how you run your venture. Good — because it's also part of how your competitor runs theirs. When everyone has the brilliant assistant, nobody has an advantage. Today is about where the advantage moved."* This one beat converts the advanced half from "I know this already" to "this is about me."</a:t>
+            </a:r>
+          </a:p>
+          <a:p/>
+          <a:p>
+            <a:r>
               <a:t>Now the provocation — deliver it as your own claim, don't read the quote block. The question at the end ("where does your edge actually live?") is the whole hour; let it hang for two seconds.</a:t>
             </a:r>
           </a:p>
@@ -544,7 +550,7 @@
           <a:p/>
           <a:p>
             <a:r>
-              <a:t>**Do:** glance at the poll histogram. Mostly A/B → slow the follow-along later. Mostly C/D → push the parallel work harder.</a:t>
+              <a:t>**Do:** if the live histogram contradicts the pre-poll (more A/B than expected), drop the "half of you" line to *"many of you"* and slow the follow-along instruction later — the beat still works.</a:t>
             </a:r>
           </a:p>
           <a:p/>
@@ -1124,6 +1130,12 @@
           <a:p/>
           <a:p>
             <a:r>
+              <a:t>**Frame both traps for heavy users, not beginners:** *"These two get worse the more you use it — familiarity breeds trust. If AI already runs half your workflow, you're consuming more of its output than anyone, and this tax compounds."* The advanced half thinks they're past this; that belief is the trap.</a:t>
+            </a:r>
+          </a:p>
+          <a:p/>
+          <a:p>
+            <a:r>
               <a:t>The cost, for founders specifically: praise stops iteration. *"The most dangerous thing a founder can hear in month one is 'great idea' — because you stop stress-testing exactly when stress-testing is cheapest."*</a:t>
             </a:r>
           </a:p>
@@ -1218,6 +1230,12 @@
           <a:p/>
           <a:p>
             <a:r>
+              <a:t>**For the daily users specifically:** *"This one bites hardest the more you delegate — because the more of your venture AI runs, the more pages you're reading that you can't check."* The heavier the usage, the more relevant, not less.</a:t>
+            </a:r>
+          </a:p>
+          <a:p/>
+          <a:p>
+            <a:r>
               <a:t>Defence in one line: be *most* sceptical where you know *least* — inverted from what feels natural.</a:t>
             </a:r>
           </a:p>
@@ -1324,6 +1342,12 @@
           <a:p/>
           <a:p>
             <a:r>
+              <a:t>**Fast-finisher escalation (operator-heavy room will need it):** *"Done before me? Go to the starter prompts on the site and run the board of directors on your idea."* Say it once here; repeat as needed during the moves.</a:t>
+            </a:r>
+          </a:p>
+          <a:p/>
+          <a:p>
+            <a:r>
               <a:t>**Advance:** to slide 7 as you copy prompt 1. From here to slide 10 the deck is a backdrop.</a:t>
             </a:r>
           </a:p>
@@ -1394,13 +1418,13 @@
           <a:lstStyle/>
           <a:p>
             <a:r>
-              <a:t>**Pass 1:** paste prompt 1. While it generates, narrate the dead air: *"Watch how happy it's about to be."* Let the love-fest scroll in silence for a few seconds — the scrolling IS the joke. Then: *"It just told a stranger their idea is brilliant. That's the trap from slide four, live — and it would say it to every founder in this room."*</a:t>
+              <a:t>**Pass 1 — frame it as the control, not a lesson.** An operator will bristle at "here's how you might prompt" (*I'd never prompt like that*). So say it straight: *"None of you would paste a prompt this lazy. But this is the baseline the whole market is producing — listen to what everyone else's pitch deck sounds like."* While it generates, narrate the dead air: *"Watch how happy it's about to be."* Let the love-fest scroll in silence — the scrolling IS the joke. Then: *"It just told a stranger their idea is brilliant. That's the trap from slide four, live — and it says it to every founder who asks."*</a:t>
             </a:r>
           </a:p>
           <a:p/>
           <a:p>
             <a:r>
-              <a:t>**Pass 2:** back to the site — prompt 2. Before sending, point at the slide's Role · Task · **Context** · Format and say what the pasted version doesn't: Context is the only part the model can't invent. Dave's context — the $150–400k sole trader, the bookkeeper-shaped competitors, the penalties-not-deductions bet — took a founder to know.</a:t>
+              <a:t>**Pass 2 — the point is strategy, not prompt technique.** Half this room knows RTCF mechanically; almost none of them treat their context as the moat. Before sending, point at the slide's Role · Task · **Context** · Format and land it at that altitude: *"Context is the only line the model can't invent — and the only line your competitor can't copy. It's your defensible asset; the discipline is injecting it every single time."* Dave's context — the $150–400k sole trader, the bookkeeper-shaped competitors, the penalties-not-deductions bet — took a founder to know.</a:t>
             </a:r>
           </a:p>
           <a:p/>
@@ -1606,7 +1630,7 @@
           <a:p/>
           <a:p>
             <a:r>
-              <a:t>One-line nod, no more: the style-brief trick makes this permanent — it's linked on the site.</a:t>
+              <a:t>One-line nod: the style-brief trick makes this permanent — it's linked on the site. **(Stretch lever for an advanced room: make this a 3-minute segment — generate a style brief live from the voice sample and paste it into custom instructions. Daily users use AI constantly and almost never systematise this.)**</a:t>
             </a:r>
           </a:p>
           <a:p/>

</xml_diff>

<commit_message>
Promote the board of directors to planned stretch at slide 10
Final poll: 27/32 in the top two bands — the live block will likely
run fast, and the organisers love this beat. Run it live on the tradie
idea at ~45:00 if time allows.

Co-Authored-By: Claude Fable 5 <noreply@anthropic.com>
</commit_message>
<xml_diff>
--- a/slides/deck-presenter.pptx
+++ b/slides/deck-presenter.pptx
@@ -627,6 +627,12 @@
           <a:p>
             <a:r>
               <a:t>The slide lists them; you only connect and locate. Devil's advocate — *"you just watched it."* Board of directors — one colour line: *"the CFO in that room will hate your pricing; better to hear it from a fake CFO for free."* VET — point forward: *"that one earns its keep in two minutes."* All three prompts on the site.</a:t>
+            </a:r>
+          </a:p>
+          <a:p/>
+          <a:p>
+            <a:r>
+              <a:t>**Planned stretch #1 lives here (likely needed — an operator room runs the live block fast):** if you're at this slide before ~45:00, run the board of directors live on Dave's idea — starter prompt from the site, same chat thread. Three voices come back; point at the disagreement: *"Notice they don't agree. That's the point — they advise, you decide. An answer machine gives you one answer; a board gives you a decision to make."* 3–4 minutes, and it's the beat the organisers loved.</a:t>
             </a:r>
           </a:p>
           <a:p/>

</xml_diff>

<commit_message>
Land the literacy line: it's the conversation, not the tool
Tools section intro now opens on "AI literacy isn't about the tool,
it's about how you converse with it" (also drops the just-starting
framing for the operator room), and the presenter notes gain it as the
Q&A deflection for tool questions.

Co-Authored-By: Claude Fable 5 <noreply@anthropic.com>
</commit_message>
<xml_diff>
--- a/slides/deck-presenter.pptx
+++ b/slides/deck-presenter.pptx
@@ -879,6 +879,12 @@
           <a:p>
             <a:r>
               <a:t>Make it one action, not four bullets: *"Tonight, before you lose the nerve: run move 1 on your real idea. Naive first, then with your edge. When you feel the difference — that feeling is the method."* Everything else — the builder, the library, Notebook, Msty — is on the site, and the site is bookmarked.</a:t>
+            </a:r>
+          </a:p>
+          <a:p/>
+          <a:p>
+            <a:r>
+              <a:t>**Q&amp;A deflection, whenever a tool question comes** ("which one should I use?", "what about Grok Bot?"): *"The names change monthly. AI literacy isn't about the tool — it's about how you converse with it. Everything you watched today works in any of them."* One sentence, back to the method.</a:t>
             </a:r>
           </a:p>
           <a:p/>

</xml_diff>

<commit_message>
Slide 2 talk track: the viral-app question, and "the average" thread
Slide 2 no longer echoes the hook: slide 1 stays the competition angle,
slide 2 becomes the capability angle — "why can't AI write the next
bestseller?" — planting "the average vs the tail," which move 3 cashes
live and the trust tool opens on as a callback.

Co-Authored-By: Claude Fable 5 <noreply@anthropic.com>
</commit_message>
<xml_diff>
--- a/slides/deck-presenter.pptx
+++ b/slides/deck-presenter.pptx
@@ -708,6 +708,12 @@
           <a:lstStyle/>
           <a:p>
             <a:r>
+              <a:t>**Open with the callback — it makes the grid click instantly:** *"Remember the question from the start — why can't AI write the next bestseller? Because it gives you the average. That's this axis. Where the average is good enough — drafts, scans, brainstorms — lean in. Where you need the tail — the call, the number, the bet — that's yours."* The grid stops being a framework and becomes the answer to the opening question.</a:t>
+            </a:r>
+          </a:p>
+          <a:p/>
+          <a:p>
+            <a:r>
               <a:t>The grid is on the slide; you supply the sorting exercise. Give the room two concrete calls to make: *"Market-sizing first pass — which box?"* (lean in, verify lightly). *"The revenue number in your pitch deck?"* (human owns it, full stop). Let them answer out loud; correcting a wrong answer teaches the grid better than presenting it.</a:t>
             </a:r>
           </a:p>
@@ -966,19 +972,25 @@
           <a:lstStyle/>
           <a:p>
             <a:r>
-              <a:t>The slide states the claim; your job is to make it personal. Land it with the room, not the abstract: *"While you've been sitting here, everyone else in this room could ask the same model for the same market scan, the same pitch, the same plan — and get the same good answer. If you all have the same brilliant assistant, none of you has an advantage."*</a:t>
+              <a:t>Slide 1 was the competition angle (everyone has it). This slide is the capability angle — don't restate, change the question. Ask the room: *"Why can't I just ask AI to write me the next viral app, or the next bestseller? It has read every bestseller ever written. It knows every app that ever went viral. So — why can't it?"* Let it hang. If someone offers an answer, take it and build on it, don't correct it.</a:t>
             </a:r>
           </a:p>
           <a:p/>
           <a:p>
             <a:r>
-              <a:t>Don't read the three rows — point at the last one and slow down on **judgement**: taste, context, the thing no identical model can copy. This claim comes back twice more (after the two-pass reveal, and at the close); it earns belief in the demo, not here.</a:t>
+              <a:t>The answer plants the hour's key word: it gives you the **average**. It's a machine for the centre of the distribution — the most plausible next thing, synthesised from everything everyone has already done. Fluent, usually right, and identical for whoever asks. But a bestseller lives in the *tail*: a taste call, a timing bet, a contrarian read the average disagrees with. The tail isn't in the model. It's in you.</a:t>
             </a:r>
           </a:p>
           <a:p/>
           <a:p>
             <a:r>
-              <a:t>**Advance:** as soon as "judgement" lands. Don't linger — this slide is a promise, not a proof.</a:t>
+              <a:t>Now point at the slide's last row and give the tail its name: **judgement** — taste, context, the variation no identical model can reproduce. "The average" comes back twice, on purpose: the generic pitch in move 3 *is* the average, live — and the trust tool's first axis is literally named for it.</a:t>
+            </a:r>
+          </a:p>
+          <a:p/>
+          <a:p>
+            <a:r>
+              <a:t>**Advance:** the moment "the tail is in you" lands. Don't linger — this slide is a promise, not a proof.</a:t>
             </a:r>
           </a:p>
         </p:txBody>
@@ -1624,7 +1636,7 @@
           <a:lstStyle/>
           <a:p>
             <a:r>
-              <a:t>Pass 1 (prompt 5): when the generic pitch appears, ask the room, don't tell: *"Would you remember this tomorrow? Neither would an investor."*</a:t>
+              <a:t>Pass 1 (prompt 5): when the generic pitch appears, ask the room, don't tell: *"Would you remember this tomorrow? Neither would an investor."* Then cash slide 2's promise: *"This is the average, live — the centre of the distribution. Every founder who asks gets this pitch."*</a:t>
             </a:r>
           </a:p>
           <a:p/>

</xml_diff>

<commit_message>
Make the move 1-2 reveal robust to no-sycophancy pass 1
Gemini dry run (18 Aug): the naive prompt returns a critical market
report, not a love-fest. Reframe the reveal on sameness ("either way,
the average"), show pass 2's assumptions mapping 1:1 to the context
lines, and make the move 2 arc callback use whatever pass 1 actually
was.

Co-Authored-By: Claude Fable 5 <noreply@anthropic.com>
</commit_message>
<xml_diff>
--- a/slides/deck-presenter.pptx
+++ b/slides/deck-presenter.pptx
@@ -1442,19 +1442,25 @@
           <a:lstStyle/>
           <a:p>
             <a:r>
-              <a:t>**Pass 1 — frame it as the control, not a lesson.** An operator will bristle at "here's how you might prompt" (*I'd never prompt like that*). So say it straight: *"None of you would paste a prompt this lazy. But this is the baseline the whole market is producing — listen to what everyone else's pitch deck sounds like."* While it generates, narrate the dead air: *"Watch how happy it's about to be."* Let the love-fest scroll in silence — the scrolling IS the joke. Then: *"It just told a stranger their idea is brilliant. That's the trap from slide four, live — and it says it to every founder who asks."*</a:t>
+              <a:t>**Pass 1 — frame it as the control, not a lesson.** An operator will bristle at "here's how you might prompt" (*I'd never prompt like that*). So say it straight: *"None of you would paste a prompt this lazy. But this is the baseline — watch what the market gets."*</a:t>
             </a:r>
           </a:p>
           <a:p/>
           <a:p>
             <a:r>
+              <a:t>**Don't promise flattery — promise sameness.** Dry run on Gemini (18 Aug): the naive prompt returned no love-fest but a competent, critical consultant's report — competitors, risks, a validation plan. Current models often skip sycophancy on task-asks ("help me validate"); it still shows on opinion-asks ("what do you think?"). So the reveal line must work for either outcome, and it does: *"Notice the one thing this answer can't be: specific to me. If it flatters me — everyone gets flattered. If it's this market report — everyone gets this exact report; its 'how to win' section is the conventional wisdom of the space, and if we all followed it we'd all build the same app. Either way: the average, live."* (If it DOES gush: name trap 1 from slide four, live — a gift, take it.)</a:t>
+            </a:r>
+          </a:p>
+          <a:p/>
+          <a:p>
+            <a:r>
               <a:t>**Pass 2 — the point is strategy, not prompt technique.** Half this room knows RTCF mechanically; almost none of them treat their context as the moat. Before sending, point at the slide's Role · Task · **Context** · Format and land it at that altitude: *"Context is the only line the model can't invent — and the only line your competitor can't copy. It's your defensible asset; the discipline is injecting it every single time."* Dave's context — the $150–400k sole trader, the bookkeeper-shaped competitors, the penalties-not-deductions bet — took a founder to know.</a:t>
             </a:r>
           </a:p>
           <a:p/>
           <a:p>
             <a:r>
-              <a:t>When it returns, the reveal, slowly: *"Same model. Same idea. Sixty seconds apart. The AI did not get smarter — I directed it."* Thesis, second landing.</a:t>
+              <a:t>When it returns, show the aiming — the three assumptions are the three context lines handed back as testable risks, one for one (dry run confirms Gemini does this): servo photo → will they open an app at the pump; bookkeeper bet → standalone value vs churn back to full accounting; penalties bet → will saved fines be attributed and paid for. Then the reveal, slowly: *"Same model. Same idea. Sixty seconds apart. The AI did not get smarter — I aimed it."* Thesis, second landing.</a:t>
             </a:r>
           </a:p>
           <a:p/>
@@ -1542,7 +1548,7 @@
           <a:p/>
           <a:p>
             <a:r>
-              <a:t>**The arc — name it the moment the verdict lands:** *"Twenty minutes ago this model said 'genuinely brilliant.' Now it says PIVOT and prescribes a fifty-dollar experiment. Cheerleader, honest critic, cheap test — same thread. That arc is the entire session."*</a:t>
+              <a:t>**The arc — name it the moment the verdict lands, using whatever pass 1 actually was:** *"Twenty minutes ago this model gave me [the everyone-gets-it market report / a round of applause]. Now it's naming the single assumption most likely to kill this, and the cheapest experiment to test it. Generic, to aimed, to a decision — that arc is the entire session in one thread."*</a:t>
             </a:r>
           </a:p>
           <a:p/>

</xml_diff>

<commit_message>
Fold the Claude dry run into slide 7: run Gemini live
Claude's richer answers front-run moves 2 and 4, so Gemini (format-
compliant, three clean lines) carries the projector; Claude becomes
Q&A depth. Adds the two-vendors-same-report reveal, the "model asks
for my edge" line, and the unverifiable-competitor-list beat as live
trap 2 / VET ammunition.

Co-Authored-By: Claude Fable 5 <noreply@anthropic.com>
</commit_message>
<xml_diff>
--- a/slides/deck-presenter.pptx
+++ b/slides/deck-presenter.pptx
@@ -1448,7 +1448,19 @@
           <a:p/>
           <a:p>
             <a:r>
-              <a:t>**Don't promise flattery — promise sameness.** Dry run on Gemini (18 Aug): the naive prompt returned no love-fest but a competent, critical consultant's report — competitors, risks, a validation plan. Current models often skip sycophancy on task-asks ("help me validate"); it still shows on opinion-asks ("what do you think?"). So the reveal line must work for either outcome, and it does: *"Notice the one thing this answer can't be: specific to me. If it flatters me — everyone gets flattered. If it's this market report — everyone gets this exact report; its 'how to win' section is the conventional wisdom of the space, and if we all followed it we'd all build the same app. Either way: the average, live."* (If it DOES gush: name trap 1 from slide four, live — a gift, take it.)</a:t>
+              <a:t>**Run the live demo on Gemini.** Dry runs (18 Aug) on both Gemini and Claude: Gemini obeys the Format line — three assumptions, one line each — which gives the clean essay-vs-three-lines contrast on screen and leaves prompts 3–4 something to do. Claude's answers are richer but front-run move 2 and the cheapest-experiment beat (it volunteered a $300 shoebox test in pass 2). Claude output = Q&amp;A/backup depth, and a bonus line: its naive answer literally asked for the wedge — *"even the model knows what's missing from this prompt: it's asking for my edge."*</a:t>
+            </a:r>
+          </a:p>
+          <a:p/>
+          <a:p>
+            <a:r>
+              <a:t>**Don't promise flattery — promise sameness.** Both models returned no love-fest on the naive prompt but a competent, critical consultant's report — competitors, risks, a validation plan. Sycophancy still shows on opinion-asks ("what do you think?"), not task-asks. The reveal works for any outcome: *"I ran this on two different companies' models last night — different vendors, same report. Notice the one thing this answer can't be: specific to me. If it flatters me — everyone gets flattered. If it's this market report — everyone gets this exact report. Either way: the average, live."* (If it DOES gush: name trap 1 from slide four, live — a gift, take it.)</a:t>
+            </a:r>
+          </a:p>
+          <a:p/>
+          <a:p>
+            <a:r>
+              <a:t>**If a confident competitor list appears (Claude named six, several unverifiable): that's trap 2, live.** *"Six competitors, named with confidence. Which are real? You can't tell from up here — smoothness isn't accuracy. That's why VET exists."* Assert unverifiability, never that a specific one is fake — you can't check from the podium either; that's the point.</a:t>
             </a:r>
           </a:p>
           <a:p/>

</xml_diff>

<commit_message>
Slide 6: floor guidance for mixed models and research modes
Naive prompt unchanged (it's the control; every model's reaction is
the lesson). New notes: name model heterogeneity as lesson one, one
rule (decline research/agent modes — conversing, not commissioning;
research belongs in the verify column), and harvest differences with
"who got something different?", capped at two.

Co-Authored-By: Claude Fable 5 <noreply@anthropic.com>
</commit_message>
<xml_diff>
--- a/slides/deck-presenter.pptx
+++ b/slides/deck-presenter.pptx
@@ -1361,6 +1361,18 @@
           <a:p>
             <a:r>
               <a:t>**Do, in order:** (1) companion site on the projector, scroll to the session prompts — say *"everything I paste today comes from your handout, in order — nothing up my sleeve."* (2) Fresh chat tab beside it. (3) Confirm the room is in: *"One of the three free chats on screen — you run your idea in parallel, or just watch. Both work."*</a:t>
+            </a:r>
+          </a:p>
+          <a:p/>
+          <a:p>
+            <a:r>
+              <a:t>**Mixed models on the floor — name it as lesson one, then set one rule.** (Dry runs: Gemini writes a market report, Claude writes one and asks for your wedge, Fable offers a 10-minute Research mode.) Say: *"You're on different models, and you'll get different answers — different formats, different voices; one of them may offer to go away and research for ten minutes. That's not a bug — it's the first finding: none of them will be specific to you until you make them."* The rule: decline research/agent modes today — *"we're conversing, not commissioning. That button is ten minutes of very thorough research into the market everyone can see — press it in move 2, when you've got an assumption worth verifying."* (Research mode = the verify column of the trust tool — the callback lands at slide 11.)</a:t>
+            </a:r>
+          </a:p>
+          <a:p/>
+          <a:p>
+            <a:r>
+              <a:t>**Harvest the differences, don't fight them:** after each pass ask *"who got something different?"* — take one or two, max. A clarifying question, a research offer, a different format: free teaching material. More than two and you lose the clock.</a:t>
             </a:r>
           </a:p>
           <a:p/>

</xml_diff>

<commit_message>
Slide 9 meta-beat: the comparison itself is the human in the loop
Said once, after the side-by-side silence: nobody ranked the two
pitches — the room judged them, proving the thesis on themselves.

Co-Authored-By: Claude Fable 5 <noreply@anthropic.com>
</commit_message>
<xml_diff>
--- a/slides/deck-presenter.pptx
+++ b/slides/deck-presenter.pptx
@@ -1679,6 +1679,12 @@
           <a:p>
             <a:r>
               <a:t>Put both pitches side by side and shut up for five seconds. Then: *"Nothing changed except whose words went in. The difference is the edge."*</a:t>
+            </a:r>
+          </a:p>
+          <a:p/>
+          <a:p>
+            <a:r>
+              <a:t>**Then the meta-beat — once, here, nowhere else:** *"And notice what just happened in the silence. Nobody told you the second one was better. No model ranked them. You judged it — instantly. That comparison you just made in your head is the one thing that never went to the cloud. That's the human in the loop — and it's the part you can't delegate."* The room just proved the thesis on themselves; caption it and move on.</a:t>
             </a:r>
           </a:p>
           <a:p/>

</xml_diff>

<commit_message>
Slide 7: the suggestion-chip beat — who sets the agenda
Gemini offers follow-up chips after pass 2; half a beat names them as
the model offering to drive, then pastes prompt 3 anyway. Same
discipline as declining Research mode.

Co-Authored-By: Claude Fable 5 <noreply@anthropic.com>
</commit_message>
<xml_diff>
--- a/slides/deck-presenter.pptx
+++ b/slides/deck-presenter.pptx
@@ -1491,6 +1491,12 @@
           <a:p>
             <a:r>
               <a:t>**Hold in your head:** this same model calls the idea a PIVOT with a $50 experiment in move 2. Don't foreshadow it to the room — the surprise is the payoff.</a:t>
+            </a:r>
+          </a:p>
+          <a:p/>
+          <a:p>
+            <a:r>
+              <a:t>**The suggestion chips (Gemini offers "where should we focus next?" after pass 2) — half a beat, not an apology:** *"See these? The model's offering to drive. They're reasonable — and they're follow-ups to* its *answer, not* my *priorities. At home, click them when they match where you were already going. Just notice who decided. Today, we drive: why does this fail?"* (If its first chip is close to the pressure-test anyway, add: *"its suggestion is near where I'm headed — but I'll frame it my way, as an attack."*) Same discipline as declining the Research button — direct it, don't delegate applies to navigation too.</a:t>
             </a:r>
           </a:p>
           <a:p/>

</xml_diff>

<commit_message>
Slide 8: the load-bearing-assumption read-aloud beat
Dry run: prompt 3 names the injected contrarian bet, verbatim, as the
assumption most likely to be wrong — the pressure-test proving the
context move one prompt later.

Co-Authored-By: Claude Fable 5 <noreply@anthropic.com>
</commit_message>
<xml_diff>
--- a/slides/deck-presenter.pptx
+++ b/slides/deck-presenter.pptx
@@ -1572,7 +1572,13 @@
           <a:lstStyle/>
           <a:p>
             <a:r>
-              <a:t>Paste prompt 3. Read the three failure reasons out loud — slower than feels natural; this is the room hearing an AI be genuinely useful for the first time today. Then prompt 4.</a:t>
+              <a:t>Paste prompt 3. Read the three failure reasons out loud — slower than feels natural; this is the room hearing an AI be genuinely useful for the first time today.</a:t>
+            </a:r>
+          </a:p>
+          <a:p/>
+          <a:p>
+            <a:r>
+              <a:t>**The load-bearing assumption is the beat (dry run: Gemini names the injected contrarian bet, verbatim, as the thing most likely to be wrong).** Read that final sentence aloud, slowly, then: *"In prompt 2 I told it my contrarian bet. In prompt 3 it's telling me my bet is the part most likely to be wrong. It's not attacking the idea — it's attacking* my claim. *It can only do that because I gave it the claim."* Optional one-liner if it fits: context compounds — aimed once in prompt 2, still aimed two prompts later. Then prompt 4.</a:t>
             </a:r>
           </a:p>
           <a:p/>

</xml_diff>

<commit_message>
Slide 8: SPK gloss and the confirmed PIVOT / $50 arc
Dry run: prompt 4 returns PIVOT, "a dead end", and a $50 five-day
Wizard-of-Oz WhatsApp test with a built-in kill criterion — the kill
normalisation now lands on that criterion.

Co-Authored-By: Claude Fable 5 <noreply@anthropic.com>
</commit_message>
<xml_diff>
--- a/slides/deck-presenter.pptx
+++ b/slides/deck-presenter.pptx
@@ -1584,13 +1584,19 @@
           <a:p/>
           <a:p>
             <a:r>
-              <a:t>**The arc — name it the moment the verdict lands, using whatever pass 1 actually was:** *"Twenty minutes ago this model gave me [the everyone-gets-it market report / a round of applause]. Now it's naming the single assumption most likely to kill this, and the cheapest experiment to test it. Generic, to aimed, to a decision — that arc is the entire session in one thread."*</a:t>
+              <a:t>**Scale/Pivot/Kill: gloss, don't teach** (this room knows the words): *"Scale — double down. Pivot — change the bet. Kill — stop."* Five words each as you paste prompt 4; the pills on the slide do the rest.</a:t>
             </a:r>
           </a:p>
           <a:p/>
           <a:p>
             <a:r>
-              <a:t>Normalise the kill — the room needs to hear a lecturer say it: *"If it had said Kill, that's a win. A fast cheap kill is the best deal in startups; the expensive version of this lesson costs eighteen months."*</a:t>
+              <a:t>**The arc — name it the moment the verdict lands (dry run: Gemini returns a bold PIVOT, calls the app-first plan "a dead end", and prescribes a $50, 5-day Wizard-of-Oz WhatsApp test):** *"Prompt 1 gave me the market report everyone gets. Prompt 4 just told me my plan is — read it — a dead end. Generic, to aimed, to a verdict — that arc is the entire session in one thread."* Two more points at the screen: the experiment carries a built-in kill criterion (no photos to WhatsApp in 14 days → KILL), and the test itself is aimed — it attacks the habit gap using the thread's own context (zero friction, no new app, where their thumbs already are).</a:t>
+            </a:r>
+          </a:p>
+          <a:p/>
+          <a:p>
+            <a:r>
+              <a:t>Normalise the kill — the room needs to hear a lecturer say it, and the kill criterion is the moment: *"It just handed me a way to find out for fifty dollars whether to stop. A fast cheap kill is the best deal in startups; the expensive version of this lesson costs eighteen months."*</a:t>
             </a:r>
           </a:p>
           <a:p/>

</xml_diff>

<commit_message>
Slide 9: accept the pivot before pitching — the human decides
After prompt 4's PIVOT, the pitch anchors on a one-line swap declaring
the idea as it now stands (the zero-UI WhatsApp shape), narrated as a
live act of judgement; room pitches their own post-verdict idea. Dave's
voice sample already described the pivot — noted as a bonus beat.

Co-Authored-By: Claude Fable 5 <noreply@anthropic.com>
</commit_message>
<xml_diff>
--- a/slides/deck-presenter.pptx
+++ b/slides/deck-presenter.pptx
@@ -1684,13 +1684,19 @@
           <a:lstStyle/>
           <a:p>
             <a:r>
+              <a:t>**First: accept the pivot, out loud — the human decides.** *"The verdict said pivot. I accept it — my call, not its."* Then paste prompt 5 with ONE line swapped to the idea as it now stands (*"a zero-UI receipt service for Australian tradies — text a photo of any receipt to a WhatsApp number, GST extracted, BAS-ready summary to your bookkeeper monthly"*), and say why: *"I'm changing one line of the handout prompt — because the idea changed, and I decided to accept that. The prompts are the method; the idea is always yours."* Room instruction: *"pitch YOUR idea as it now stands — Scale, pitch it proudly; Pivot, pitch the new shape; Kill — pitch your next idea."*</a:t>
+            </a:r>
+          </a:p>
+          <a:p/>
+          <a:p>
+            <a:r>
               <a:t>Pass 1 (prompt 5): when the generic pitch appears, ask the room, don't tell: *"Would you remember this tomorrow? Neither would an investor."* Then cash slide 2's promise: *"This is the average, live — the centre of the distribution. Every founder who asks gets this pitch."*</a:t>
             </a:r>
           </a:p>
           <a:p/>
           <a:p>
             <a:r>
-              <a:t>Pass 2 (prompt 6): before sending, read Dave's voice sample aloud with the accent it deserves — "they don't hate tax, they hate the chair" gets a laugh and *earns* the contrast. The room pastes their own writing via the template.</a:t>
+              <a:t>Pass 2 (prompt 6): before sending, read Dave's voice sample aloud with the accent it deserves — "they don't hate tax, they hate the chair" gets a laugh and *earns* the contrast. The room pastes their own writing via the template. Bonus if it fits: Dave's sample was already pitching the pivot — *"one photo at the servo, snap it, chuck it, drive off"* IS the WhatsApp pipeline. *"His own words found it before the model did."*</a:t>
             </a:r>
           </a:p>
           <a:p/>

</xml_diff>

<commit_message>
Slide 3: expectation-setting beat — the tool is the easy part
The credibility line earns the refusal: not a power-user masterclass;
the hour is the judgement in the conversation, not the tool.

Co-Authored-By: Claude Fable 5 <noreply@anthropic.com>
</commit_message>
<xml_diff>
--- a/slides/deck-presenter.pptx
+++ b/slides/deck-presenter.pptx
@@ -1067,6 +1067,12 @@
           <a:p>
             <a:r>
               <a:t>The one line to deliver with a beat of silence after: *"the deck you're watching, the site you scanned, and the poll you just answered were all built in conversation with AI."* Don't elaborate. Understatement is the credibility.</a:t>
+            </a:r>
+          </a:p>
+          <a:p/>
+          <a:p>
+            <a:r>
+              <a:t>**Then set expectations — the credibility earns this refusal:** *"So yes — you can build real software in conversation with AI; that's where those thirty tools came from. But I'm not here to show you how clever I am with AI — and in one hour I couldn't make you clever with it either. The tool is the easy part, and everyone in this room has the same one. I'm here for the other part: the judgement you bring to the conversation. That's the only part that's yours."* Keep it this short — longer reads as apology. (This also pre-plants the literacy line for the close.)</a:t>
             </a:r>
           </a:p>
           <a:p/>

</xml_diff>

<commit_message>
Slide 9: confirmed comparison beat — instruction vs belief
Dry run of prompts 5-6 complete: pass 1 is edge-aware but agency
voice, pass 2 leads with the conviction, customer, and bet. The beat
compares the two opening lines.

Co-Authored-By: Claude Fable 5 <noreply@anthropic.com>
</commit_message>
<xml_diff>
--- a/slides/deck-presenter.pptx
+++ b/slides/deck-presenter.pptx
@@ -1708,7 +1708,13 @@
           <a:p/>
           <a:p>
             <a:r>
-              <a:t>Put both pitches side by side — they're two consecutive replies in the same thread; copy the two 60-worders into a blank doc (or scroll between them) so the room sees both at once — and shut up for five seconds. Then: *"Nothing changed except whose words went in. The difference is the edge."* (If pass 1 came out edge-aware because the thread already holds Dave's context, narrow the caption to voice: *"competent — but it could be anyone's. Now listen to Dave's."*)</a:t>
+              <a:t>Put both pitches side by side — they're two consecutive replies in the same thread; copy the two 60-worders into a blank doc (or scroll between them) so the room sees both at once — and shut up for five seconds.</a:t>
+            </a:r>
+          </a:p>
+          <a:p/>
+          <a:p>
+            <a:r>
+              <a:t>**The comparison beat (dry-run confirmed: pass 1 comes out edge-aware but in agency voice — use the "could be anyone's" caption):** point at the two OPENING lines. Pass 1 opens with an instruction ("Stop stuffing paper receipts into your glovebox") — an ad; any copywriter writes it. Pass 2 opens with a belief ("Tradies don't hate tax — they hate sitting at a laptop at 9pm") — then the customer, then the bet. *"The first pitch sells a product. The second sells a founder's view of the world — and investors fund the second, because the product will change and the view is what steers it. Nothing changed except whose words went in."*</a:t>
             </a:r>
           </a:p>
           <a:p/>

</xml_diff>

<commit_message>
Slide 10: board-of-directors dry run — adapted prompt, three beats, VET by pointing
The adapted demo prompt (site stays generic) ends "I will decide" —
narrated. Output confirms disagreement, the marketer as relocated
sycophancy, and customer-only failure modes; VET is taught against the
board's own unverified claims, no extra prompt.

Co-Authored-By: Claude Fable 5 <noreply@anthropic.com>
</commit_message>
<xml_diff>
--- a/slides/deck-presenter.pptx
+++ b/slides/deck-presenter.pptx
@@ -632,7 +632,19 @@
           <a:p/>
           <a:p>
             <a:r>
-              <a:t>**Planned stretch #1 lives here (likely needed — an operator room runs the live block fast):** if you're at this slide before ~45:00, run the board of directors live on Dave's idea — starter prompt from the site, same chat thread. Three voices come back; point at the disagreement: *"Notice they don't agree. That's the point — they advise, you decide. An answer machine gives you one answer; a board gives you a decision to make."* 3–4 minutes, and it's the beat the organisers loved.</a:t>
+              <a:t>**Planned stretch #1 lives here (likely needed — an operator room runs the live block fast):** if you're at this slide before ~45:00, run the board of directors live in the same thread, using the adapted prompt (site version stays generic): *"Answer as a panel, each in their own voice: (1) a cautious CFO, (2) my most skeptical customer, (3) a growth-hungry marketer. Each gives an honest take on this WhatsApp receipt photo idea, then stops. I will decide."* Point at your own last line before sending: *"the whole hour in five words."* 3–4 minutes, and it's the beat the organisers loved.</a:t>
+            </a:r>
+          </a:p>
+          <a:p/>
+          <a:p>
+            <a:r>
+              <a:t>**Three beats in the output (dry-run confirmed):** (1) they disagree — CFO "not venture-backable", customer "I'll stick to the glovebox", marketer "pure gold" — *"an answer machine gives you one answer; a board gives you a decision to make."* (2) The cheerleader took a seat: the marketer IS trap 1, relocated — you weigh that voice, not obey it. (3) The customer surfaces failure modes nothing else found (grease, dropout at the trade desk, faded thermal paper).</a:t>
+            </a:r>
+          </a:p>
+          <a:p/>
+          <a:p>
+            <a:r>
+              <a:t>**VET: discuss by pointing at this very output — no extra prompt.** The board just made three smooth, specific, unverified claims (per-message API costs, thermal fade, "$100k ARR on referrals"). *"Which do you VET first? The one your next decision leans on — the API cost, inside the CFO's kill argument. Verify the source, Explain it back, Test the edges. Tonight's homework; prompts on the site."*</a:t>
             </a:r>
           </a:p>
           <a:p/>

</xml_diff>

<commit_message>
Slide 13: time-permitting Notebook closer — the conversation as source
Closer-options Option B upgraded: save the live thread to a Gemini
Notebook and generate one pre-tested artifact, framed via the trust
tool (grounded, not the average), chained to the unpressed Research
button; always before the triad, hard 3-minute cap.

Co-Authored-By: Claude Fable 5 <noreply@anthropic.com>
</commit_message>
<xml_diff>
--- a/slides/deck-presenter.pptx
+++ b/slides/deck-presenter.pptx
@@ -897,6 +897,12 @@
           <a:p>
             <a:r>
               <a:t>Make it one action, not four bullets: *"Tonight, before you lose the nerve: run move 1 on your real idea. Naive first, then with your edge. When you feel the difference — that feeling is the method."* Everything else — the builder, the library, Notebook, Msty — is on the site, and the site is bookmarked.</a:t>
+            </a:r>
+          </a:p>
+          <a:p/>
+          <a:p>
+            <a:r>
+              <a:t>**Time-permitting horizon closer (closer-options Option B, upgraded — no slide needed, slide 13 stays up; ALWAYS before the triad, never after):** save the live conversation to a Gemini Notebook and generate the ONE artifact you pre-tested tonight for speed (text artifacts fast; audio overview takes minutes — if you want it, kick it off and keep talking). Framing, so it's thesis not showcase: *"Notice what this is not — it's not the average. It's grounded in OUR conversation; it cites what we said. Same model family, different placement on the grid."* Chain the research use off the morning: *"Remember the Research button we didn't press? Tonight, that plus a Notebook is how you VET a competitor list — everything public, grounded, cited."* One sentence on the ecosystem, no demo: *"Gemini's also growing agent features and plugs into Docs and Sheets — the honest trade: not the strongest model, but when your method is conversation, the model race matters less than workflow fit and the price of free."* Hard cap 3 minutes.</a:t>
             </a:r>
           </a:p>
           <a:p/>

</xml_diff>

<commit_message>
Slide 13: promise the live thread and notebook on the site
Share the live conversation (from the burner account) after the
session, dry-run versions as fallback; links added to the site that
afternoon as the retention hook.

Co-Authored-By: Claude Fable 5 <noreply@anthropic.com>
</commit_message>
<xml_diff>
--- a/slides/deck-presenter.pptx
+++ b/slides/deck-presenter.pptx
@@ -897,6 +897,12 @@
           <a:p>
             <a:r>
               <a:t>Make it one action, not four bullets: *"Tonight, before you lose the nerve: run move 1 on your real idea. Naive first, then with your edge. When you feel the difference — that feeling is the method."* Everything else — the builder, the library, Notebook, Msty — is on the site, and the site is bookmarked.</a:t>
+            </a:r>
+          </a:p>
+          <a:p/>
+          <a:p>
+            <a:r>
+              <a:t>**The promise (retention hook — share the LIVE thread, not the dry run):** *"Everything I typed today — the full conversation, and the notebook built from it — will be on the companion site this afternoon."* Share from the burner account (test tonight that both share links open for non-owners; notebook shares may need sign-in). The dry-run versions are the fallback only if the live beat got cut or broke. Add the links to the site after the session.</a:t>
             </a:r>
           </a:p>
           <a:p/>

</xml_diff>